<commit_message>
Add tittle list for presentation
</commit_message>
<xml_diff>
--- a/6301-1-presentation.pptx
+++ b/6301-1-presentation.pptx
@@ -6,6 +6,7 @@
   </p:sldMasterIdLst>
   <p:sldIdLst>
     <p:sldId id="256" r:id="rId2"/>
+    <p:sldId id="257" r:id="rId3"/>
   </p:sldIdLst>
   <p:sldSz cx="12192000" cy="6858000"/>
   <p:notesSz cx="6858000" cy="9144000"/>
@@ -105,6 +106,58 @@
     </a:lvl9pPr>
   </p:defaultTextStyle>
 </p:presentation>
+</file>
+
+<file path=ppt/changesInfos/changesInfo1.xml><?xml version="1.0" encoding="utf-8"?>
+<pc:chgInfo xmlns:a="http://schemas.openxmlformats.org/drawingml/2006/main" xmlns:r="http://schemas.openxmlformats.org/officeDocument/2006/relationships" xmlns:ac="http://schemas.microsoft.com/office/drawing/2013/main/command" xmlns:pc="http://schemas.microsoft.com/office/powerpoint/2013/main/command">
+  <pc:docChgLst>
+    <pc:chgData name="Mariya Miroshnik" userId="2634db3ebd27adf4" providerId="LiveId" clId="{1A964A56-864F-45CB-9DBB-924C6FB3B4CA}"/>
+    <pc:docChg chg="undo custSel addSld modSld">
+      <pc:chgData name="Mariya Miroshnik" userId="2634db3ebd27adf4" providerId="LiveId" clId="{1A964A56-864F-45CB-9DBB-924C6FB3B4CA}" dt="2026-05-05T09:07:38.270" v="156" actId="680"/>
+      <pc:docMkLst>
+        <pc:docMk/>
+      </pc:docMkLst>
+      <pc:sldChg chg="addSp delSp modSp mod">
+        <pc:chgData name="Mariya Miroshnik" userId="2634db3ebd27adf4" providerId="LiveId" clId="{1A964A56-864F-45CB-9DBB-924C6FB3B4CA}" dt="2026-05-05T09:07:36.331" v="155" actId="22"/>
+        <pc:sldMkLst>
+          <pc:docMk/>
+          <pc:sldMk cId="254926094" sldId="256"/>
+        </pc:sldMkLst>
+        <pc:spChg chg="mod">
+          <ac:chgData name="Mariya Miroshnik" userId="2634db3ebd27adf4" providerId="LiveId" clId="{1A964A56-864F-45CB-9DBB-924C6FB3B4CA}" dt="2026-05-05T09:06:35.518" v="14" actId="20577"/>
+          <ac:spMkLst>
+            <pc:docMk/>
+            <pc:sldMk cId="254926094" sldId="256"/>
+            <ac:spMk id="2" creationId="{D720917F-D317-86A7-7700-773022ED347F}"/>
+          </ac:spMkLst>
+        </pc:spChg>
+        <pc:spChg chg="mod">
+          <ac:chgData name="Mariya Miroshnik" userId="2634db3ebd27adf4" providerId="LiveId" clId="{1A964A56-864F-45CB-9DBB-924C6FB3B4CA}" dt="2026-05-05T09:07:31.845" v="153" actId="27636"/>
+          <ac:spMkLst>
+            <pc:docMk/>
+            <pc:sldMk cId="254926094" sldId="256"/>
+            <ac:spMk id="3" creationId="{17B0F3A4-6E6C-E023-5633-992EE631E60B}"/>
+          </ac:spMkLst>
+        </pc:spChg>
+        <pc:spChg chg="add del">
+          <ac:chgData name="Mariya Miroshnik" userId="2634db3ebd27adf4" providerId="LiveId" clId="{1A964A56-864F-45CB-9DBB-924C6FB3B4CA}" dt="2026-05-05T09:07:36.331" v="155" actId="22"/>
+          <ac:spMkLst>
+            <pc:docMk/>
+            <pc:sldMk cId="254926094" sldId="256"/>
+            <ac:spMk id="5" creationId="{9E8EFC66-C470-FDAA-E3B4-6E5251FB2EA3}"/>
+          </ac:spMkLst>
+        </pc:spChg>
+      </pc:sldChg>
+      <pc:sldChg chg="new">
+        <pc:chgData name="Mariya Miroshnik" userId="2634db3ebd27adf4" providerId="LiveId" clId="{1A964A56-864F-45CB-9DBB-924C6FB3B4CA}" dt="2026-05-05T09:07:38.270" v="156" actId="680"/>
+        <pc:sldMkLst>
+          <pc:docMk/>
+          <pc:sldMk cId="3258878711" sldId="257"/>
+        </pc:sldMkLst>
+      </pc:sldChg>
+    </pc:docChg>
+  </pc:docChgLst>
+</pc:chgInfo>
 </file>
 
 <file path=ppt/slideLayouts/slideLayout1.xml><?xml version="1.0" encoding="utf-8"?>
@@ -3339,10 +3392,15 @@
         </p:nvSpPr>
         <p:spPr/>
         <p:txBody>
-          <a:bodyPr/>
-          <a:lstStyle/>
-          <a:p>
-            <a:endParaRPr lang="ru-RU"/>
+          <a:bodyPr>
+            <a:normAutofit/>
+          </a:bodyPr>
+          <a:lstStyle/>
+          <a:p>
+            <a:r>
+              <a:rPr lang="ru-RU" dirty="0"/>
+              <a:t>АГЕНТ-НАСТАВНИК ПО УЧЕБЕ </a:t>
+            </a:r>
           </a:p>
         </p:txBody>
       </p:sp>
@@ -3362,12 +3420,60 @@
             <p:ph type="subTitle" idx="1"/>
           </p:nvPr>
         </p:nvSpPr>
-        <p:spPr/>
-        <p:txBody>
-          <a:bodyPr/>
-          <a:lstStyle/>
-          <a:p>
-            <a:endParaRPr lang="ru-RU"/>
+        <p:spPr>
+          <a:xfrm>
+            <a:off x="1524000" y="3602037"/>
+            <a:ext cx="9144000" cy="2387599"/>
+          </a:xfrm>
+        </p:spPr>
+        <p:txBody>
+          <a:bodyPr>
+            <a:normAutofit fontScale="92500" lnSpcReduction="10000"/>
+          </a:bodyPr>
+          <a:lstStyle/>
+          <a:p>
+            <a:r>
+              <a:rPr lang="ru-RU" dirty="0"/>
+              <a:t>Работу выполнили студенты группы 6301-020302</a:t>
+            </a:r>
+            <a:r>
+              <a:rPr lang="en-GB" dirty="0"/>
+              <a:t>D</a:t>
+            </a:r>
+          </a:p>
+          <a:p>
+            <a:r>
+              <a:rPr lang="ru-RU" dirty="0"/>
+              <a:t>Мирошник М. (капитан)</a:t>
+            </a:r>
+          </a:p>
+          <a:p>
+            <a:r>
+              <a:rPr lang="ru-RU" dirty="0"/>
+              <a:t>Хархавкина М. </a:t>
+            </a:r>
+          </a:p>
+          <a:p>
+            <a:r>
+              <a:rPr lang="ru-RU" dirty="0"/>
+              <a:t>Свистун С. </a:t>
+            </a:r>
+          </a:p>
+          <a:p>
+            <a:r>
+              <a:rPr lang="ru-RU" dirty="0" err="1"/>
+              <a:t>Микуров</a:t>
+            </a:r>
+            <a:r>
+              <a:rPr lang="ru-RU" dirty="0"/>
+              <a:t> Д. </a:t>
+            </a:r>
+          </a:p>
+          <a:p>
+            <a:r>
+              <a:rPr lang="ru-RU" dirty="0"/>
+              <a:t>Кокорев М. </a:t>
+            </a:r>
           </a:p>
         </p:txBody>
       </p:sp>
@@ -3375,6 +3481,86 @@
     <p:extLst>
       <p:ext uri="{BB962C8B-B14F-4D97-AF65-F5344CB8AC3E}">
         <p14:creationId xmlns:p14="http://schemas.microsoft.com/office/powerpoint/2010/main" val="254926094"/>
+      </p:ext>
+    </p:extLst>
+  </p:cSld>
+  <p:clrMapOvr>
+    <a:masterClrMapping/>
+  </p:clrMapOvr>
+</p:sld>
+</file>
+
+<file path=ppt/slides/slide2.xml><?xml version="1.0" encoding="utf-8"?>
+<p:sld xmlns:a="http://schemas.openxmlformats.org/drawingml/2006/main" xmlns:r="http://schemas.openxmlformats.org/officeDocument/2006/relationships" xmlns:p="http://schemas.openxmlformats.org/presentationml/2006/main">
+  <p:cSld>
+    <p:spTree>
+      <p:nvGrpSpPr>
+        <p:cNvPr id="1" name=""/>
+        <p:cNvGrpSpPr/>
+        <p:nvPr/>
+      </p:nvGrpSpPr>
+      <p:grpSpPr>
+        <a:xfrm>
+          <a:off x="0" y="0"/>
+          <a:ext cx="0" cy="0"/>
+          <a:chOff x="0" y="0"/>
+          <a:chExt cx="0" cy="0"/>
+        </a:xfrm>
+      </p:grpSpPr>
+      <p:sp>
+        <p:nvSpPr>
+          <p:cNvPr id="2" name="Заголовок 1">
+            <a:extLst>
+              <a:ext uri="{FF2B5EF4-FFF2-40B4-BE49-F238E27FC236}">
+                <a16:creationId xmlns:a16="http://schemas.microsoft.com/office/drawing/2014/main" id="{D5B66277-3DC1-7291-7CF4-E849D780BA21}"/>
+              </a:ext>
+            </a:extLst>
+          </p:cNvPr>
+          <p:cNvSpPr>
+            <a:spLocks noGrp="1"/>
+          </p:cNvSpPr>
+          <p:nvPr>
+            <p:ph type="title"/>
+          </p:nvPr>
+        </p:nvSpPr>
+        <p:spPr/>
+        <p:txBody>
+          <a:bodyPr/>
+          <a:lstStyle/>
+          <a:p>
+            <a:endParaRPr lang="ru-RU"/>
+          </a:p>
+        </p:txBody>
+      </p:sp>
+      <p:sp>
+        <p:nvSpPr>
+          <p:cNvPr id="3" name="Объект 2">
+            <a:extLst>
+              <a:ext uri="{FF2B5EF4-FFF2-40B4-BE49-F238E27FC236}">
+                <a16:creationId xmlns:a16="http://schemas.microsoft.com/office/drawing/2014/main" id="{070F49A7-83B4-9101-CDC6-F1357F20D99D}"/>
+              </a:ext>
+            </a:extLst>
+          </p:cNvPr>
+          <p:cNvSpPr>
+            <a:spLocks noGrp="1"/>
+          </p:cNvSpPr>
+          <p:nvPr>
+            <p:ph idx="1"/>
+          </p:nvPr>
+        </p:nvSpPr>
+        <p:spPr/>
+        <p:txBody>
+          <a:bodyPr/>
+          <a:lstStyle/>
+          <a:p>
+            <a:endParaRPr lang="ru-RU"/>
+          </a:p>
+        </p:txBody>
+      </p:sp>
+    </p:spTree>
+    <p:extLst>
+      <p:ext uri="{BB962C8B-B14F-4D97-AF65-F5344CB8AC3E}">
+        <p14:creationId xmlns:p14="http://schemas.microsoft.com/office/powerpoint/2010/main" val="3258878711"/>
       </p:ext>
     </p:extLst>
   </p:cSld>

</xml_diff>